<commit_message>
Refine layout and styling in presentation; adjust textbox dimensions and font size for improved aesthetics and readability.
</commit_message>
<xml_diff>
--- a/slides/presentation_v2.pptx
+++ b/slides/presentation_v2.pptx
@@ -4895,8 +4895,8 @@
         </p:nvSpPr>
         <p:spPr>
           <a:xfrm>
-            <a:off x="0" y="6263640"/>
-            <a:ext cx="411480" cy="457200"/>
+            <a:off x="0" y="6309360"/>
+            <a:ext cx="411480" cy="411480"/>
           </a:xfrm>
           <a:prstGeom prst="rect">
             <a:avLst/>
@@ -4904,13 +4904,13 @@
           <a:noFill/>
         </p:spPr>
         <p:txBody>
-          <a:bodyPr wrap="none">
+          <a:bodyPr wrap="none" lIns="0" rIns="0">
             <a:spAutoFit/>
           </a:bodyPr>
           <a:lstStyle/>
           <a:p>
             <a:pPr algn="ctr">
-              <a:defRPr sz="1200" b="1">
+              <a:defRPr sz="1100" b="1">
                 <a:solidFill>
                   <a:srgbClr val="BF9A4A"/>
                 </a:solidFill>
@@ -5217,8 +5217,8 @@
         </p:nvSpPr>
         <p:spPr>
           <a:xfrm>
-            <a:off x="0" y="6263640"/>
-            <a:ext cx="411480" cy="457200"/>
+            <a:off x="0" y="6309360"/>
+            <a:ext cx="411480" cy="411480"/>
           </a:xfrm>
           <a:prstGeom prst="rect">
             <a:avLst/>
@@ -5226,13 +5226,13 @@
           <a:noFill/>
         </p:spPr>
         <p:txBody>
-          <a:bodyPr wrap="none">
+          <a:bodyPr wrap="none" lIns="0" rIns="0">
             <a:spAutoFit/>
           </a:bodyPr>
           <a:lstStyle/>
           <a:p>
             <a:pPr algn="ctr">
-              <a:defRPr sz="1200" b="1">
+              <a:defRPr sz="1100" b="1">
                 <a:solidFill>
                   <a:srgbClr val="BF9A4A"/>
                 </a:solidFill>
@@ -5516,8 +5516,8 @@
         </p:nvSpPr>
         <p:spPr>
           <a:xfrm>
-            <a:off x="0" y="6263640"/>
-            <a:ext cx="411480" cy="457200"/>
+            <a:off x="0" y="6309360"/>
+            <a:ext cx="411480" cy="411480"/>
           </a:xfrm>
           <a:prstGeom prst="rect">
             <a:avLst/>
@@ -5525,13 +5525,13 @@
           <a:noFill/>
         </p:spPr>
         <p:txBody>
-          <a:bodyPr wrap="none">
+          <a:bodyPr wrap="none" lIns="0" rIns="0">
             <a:spAutoFit/>
           </a:bodyPr>
           <a:lstStyle/>
           <a:p>
             <a:pPr algn="ctr">
-              <a:defRPr sz="1200" b="1">
+              <a:defRPr sz="1100" b="1">
                 <a:solidFill>
                   <a:srgbClr val="BF9A4A"/>
                 </a:solidFill>
@@ -5838,8 +5838,8 @@
         </p:nvSpPr>
         <p:spPr>
           <a:xfrm>
-            <a:off x="0" y="6263640"/>
-            <a:ext cx="411480" cy="457200"/>
+            <a:off x="0" y="6309360"/>
+            <a:ext cx="411480" cy="411480"/>
           </a:xfrm>
           <a:prstGeom prst="rect">
             <a:avLst/>
@@ -5847,13 +5847,13 @@
           <a:noFill/>
         </p:spPr>
         <p:txBody>
-          <a:bodyPr wrap="none">
+          <a:bodyPr wrap="none" lIns="0" rIns="0">
             <a:spAutoFit/>
           </a:bodyPr>
           <a:lstStyle/>
           <a:p>
             <a:pPr algn="ctr">
-              <a:defRPr sz="1200" b="1">
+              <a:defRPr sz="1100" b="1">
                 <a:solidFill>
                   <a:srgbClr val="BF9A4A"/>
                 </a:solidFill>
@@ -6137,8 +6137,8 @@
         </p:nvSpPr>
         <p:spPr>
           <a:xfrm>
-            <a:off x="0" y="6263640"/>
-            <a:ext cx="411480" cy="457200"/>
+            <a:off x="0" y="6309360"/>
+            <a:ext cx="411480" cy="411480"/>
           </a:xfrm>
           <a:prstGeom prst="rect">
             <a:avLst/>
@@ -6146,13 +6146,13 @@
           <a:noFill/>
         </p:spPr>
         <p:txBody>
-          <a:bodyPr wrap="none">
+          <a:bodyPr wrap="none" lIns="0" rIns="0">
             <a:spAutoFit/>
           </a:bodyPr>
           <a:lstStyle/>
           <a:p>
             <a:pPr algn="ctr">
-              <a:defRPr sz="1200" b="1">
+              <a:defRPr sz="1100" b="1">
                 <a:solidFill>
                   <a:srgbClr val="BF9A4A"/>
                 </a:solidFill>
@@ -6259,7 +6259,7 @@
         </p:blipFill>
         <p:spPr>
           <a:xfrm>
-            <a:off x="1828800" y="1371600"/>
+            <a:off x="3419856" y="1371600"/>
             <a:ext cx="5760720" cy="3840480"/>
           </a:xfrm>
           <a:prstGeom prst="rect">
@@ -6275,8 +6275,8 @@
         </p:nvSpPr>
         <p:spPr>
           <a:xfrm>
-            <a:off x="914400" y="5349240"/>
-            <a:ext cx="10607040" cy="1325880"/>
+            <a:off x="914400" y="5394960"/>
+            <a:ext cx="10607040" cy="1280159"/>
           </a:xfrm>
           <a:prstGeom prst="rect">
             <a:avLst/>
@@ -6414,8 +6414,8 @@
         </p:nvSpPr>
         <p:spPr>
           <a:xfrm>
-            <a:off x="0" y="6263640"/>
-            <a:ext cx="411480" cy="457200"/>
+            <a:off x="0" y="6309360"/>
+            <a:ext cx="411480" cy="411480"/>
           </a:xfrm>
           <a:prstGeom prst="rect">
             <a:avLst/>
@@ -6423,13 +6423,13 @@
           <a:noFill/>
         </p:spPr>
         <p:txBody>
-          <a:bodyPr wrap="none">
+          <a:bodyPr wrap="none" lIns="0" rIns="0">
             <a:spAutoFit/>
           </a:bodyPr>
           <a:lstStyle/>
           <a:p>
             <a:pPr algn="ctr">
-              <a:defRPr sz="1200" b="1">
+              <a:defRPr sz="1100" b="1">
                 <a:solidFill>
                   <a:srgbClr val="BF9A4A"/>
                 </a:solidFill>
@@ -6536,8 +6536,8 @@
         </p:blipFill>
         <p:spPr>
           <a:xfrm>
-            <a:off x="1828800" y="1371600"/>
-            <a:ext cx="13716000" cy="3840480"/>
+            <a:off x="1133856" y="1371600"/>
+            <a:ext cx="10332720" cy="2893162"/>
           </a:xfrm>
           <a:prstGeom prst="rect">
             <a:avLst/>
@@ -6552,8 +6552,8 @@
         </p:nvSpPr>
         <p:spPr>
           <a:xfrm>
-            <a:off x="914400" y="5349240"/>
-            <a:ext cx="10607040" cy="1325880"/>
+            <a:off x="914400" y="4447641"/>
+            <a:ext cx="10607040" cy="2227478"/>
           </a:xfrm>
           <a:prstGeom prst="rect">
             <a:avLst/>
@@ -6691,8 +6691,8 @@
         </p:nvSpPr>
         <p:spPr>
           <a:xfrm>
-            <a:off x="0" y="6263640"/>
-            <a:ext cx="411480" cy="457200"/>
+            <a:off x="0" y="6309360"/>
+            <a:ext cx="411480" cy="411480"/>
           </a:xfrm>
           <a:prstGeom prst="rect">
             <a:avLst/>
@@ -6700,13 +6700,13 @@
           <a:noFill/>
         </p:spPr>
         <p:txBody>
-          <a:bodyPr wrap="none">
+          <a:bodyPr wrap="none" lIns="0" rIns="0">
             <a:spAutoFit/>
           </a:bodyPr>
           <a:lstStyle/>
           <a:p>
             <a:pPr algn="ctr">
-              <a:defRPr sz="1200" b="1">
+              <a:defRPr sz="1100" b="1">
                 <a:solidFill>
                   <a:srgbClr val="BF9A4A"/>
                 </a:solidFill>
@@ -7184,8 +7184,8 @@
         </p:nvSpPr>
         <p:spPr>
           <a:xfrm>
-            <a:off x="0" y="6263640"/>
-            <a:ext cx="411480" cy="457200"/>
+            <a:off x="0" y="6309360"/>
+            <a:ext cx="411480" cy="411480"/>
           </a:xfrm>
           <a:prstGeom prst="rect">
             <a:avLst/>
@@ -7193,13 +7193,13 @@
           <a:noFill/>
         </p:spPr>
         <p:txBody>
-          <a:bodyPr wrap="none">
+          <a:bodyPr wrap="none" lIns="0" rIns="0">
             <a:spAutoFit/>
           </a:bodyPr>
           <a:lstStyle/>
           <a:p>
             <a:pPr algn="ctr">
-              <a:defRPr sz="1200" b="1">
+              <a:defRPr sz="1100" b="1">
                 <a:solidFill>
                   <a:srgbClr val="BF9A4A"/>
                 </a:solidFill>
@@ -7506,8 +7506,8 @@
         </p:nvSpPr>
         <p:spPr>
           <a:xfrm>
-            <a:off x="0" y="6263640"/>
-            <a:ext cx="411480" cy="457200"/>
+            <a:off x="0" y="6309360"/>
+            <a:ext cx="411480" cy="411480"/>
           </a:xfrm>
           <a:prstGeom prst="rect">
             <a:avLst/>
@@ -7515,13 +7515,13 @@
           <a:noFill/>
         </p:spPr>
         <p:txBody>
-          <a:bodyPr wrap="none">
+          <a:bodyPr wrap="none" lIns="0" rIns="0">
             <a:spAutoFit/>
           </a:bodyPr>
           <a:lstStyle/>
           <a:p>
             <a:pPr algn="ctr">
-              <a:defRPr sz="1200" b="1">
+              <a:defRPr sz="1100" b="1">
                 <a:solidFill>
                   <a:srgbClr val="BF9A4A"/>
                 </a:solidFill>
@@ -7805,8 +7805,8 @@
         </p:nvSpPr>
         <p:spPr>
           <a:xfrm>
-            <a:off x="0" y="6263640"/>
-            <a:ext cx="411480" cy="457200"/>
+            <a:off x="0" y="6309360"/>
+            <a:ext cx="411480" cy="411480"/>
           </a:xfrm>
           <a:prstGeom prst="rect">
             <a:avLst/>
@@ -7814,13 +7814,13 @@
           <a:noFill/>
         </p:spPr>
         <p:txBody>
-          <a:bodyPr wrap="none">
+          <a:bodyPr wrap="none" lIns="0" rIns="0">
             <a:spAutoFit/>
           </a:bodyPr>
           <a:lstStyle/>
           <a:p>
             <a:pPr algn="ctr">
-              <a:defRPr sz="1200" b="1">
+              <a:defRPr sz="1100" b="1">
                 <a:solidFill>
                   <a:srgbClr val="BF9A4A"/>
                 </a:solidFill>
@@ -8104,8 +8104,8 @@
         </p:nvSpPr>
         <p:spPr>
           <a:xfrm>
-            <a:off x="0" y="6263640"/>
-            <a:ext cx="411480" cy="457200"/>
+            <a:off x="0" y="6309360"/>
+            <a:ext cx="411480" cy="411480"/>
           </a:xfrm>
           <a:prstGeom prst="rect">
             <a:avLst/>
@@ -8113,13 +8113,13 @@
           <a:noFill/>
         </p:spPr>
         <p:txBody>
-          <a:bodyPr wrap="none">
+          <a:bodyPr wrap="none" lIns="0" rIns="0">
             <a:spAutoFit/>
           </a:bodyPr>
           <a:lstStyle/>
           <a:p>
             <a:pPr algn="ctr">
-              <a:defRPr sz="1200" b="1">
+              <a:defRPr sz="1100" b="1">
                 <a:solidFill>
                   <a:srgbClr val="BF9A4A"/>
                 </a:solidFill>
@@ -8449,8 +8449,8 @@
         </p:nvSpPr>
         <p:spPr>
           <a:xfrm>
-            <a:off x="0" y="6263640"/>
-            <a:ext cx="411480" cy="457200"/>
+            <a:off x="0" y="6309360"/>
+            <a:ext cx="411480" cy="411480"/>
           </a:xfrm>
           <a:prstGeom prst="rect">
             <a:avLst/>
@@ -8458,13 +8458,13 @@
           <a:noFill/>
         </p:spPr>
         <p:txBody>
-          <a:bodyPr wrap="none">
+          <a:bodyPr wrap="none" lIns="0" rIns="0">
             <a:spAutoFit/>
           </a:bodyPr>
           <a:lstStyle/>
           <a:p>
             <a:pPr algn="ctr">
-              <a:defRPr sz="1200" b="1">
+              <a:defRPr sz="1100" b="1">
                 <a:solidFill>
                   <a:srgbClr val="BF9A4A"/>
                 </a:solidFill>
@@ -8771,8 +8771,8 @@
         </p:nvSpPr>
         <p:spPr>
           <a:xfrm>
-            <a:off x="0" y="6263640"/>
-            <a:ext cx="411480" cy="457200"/>
+            <a:off x="0" y="6309360"/>
+            <a:ext cx="411480" cy="411480"/>
           </a:xfrm>
           <a:prstGeom prst="rect">
             <a:avLst/>
@@ -8780,13 +8780,13 @@
           <a:noFill/>
         </p:spPr>
         <p:txBody>
-          <a:bodyPr wrap="none">
+          <a:bodyPr wrap="none" lIns="0" rIns="0">
             <a:spAutoFit/>
           </a:bodyPr>
           <a:lstStyle/>
           <a:p>
             <a:pPr algn="ctr">
-              <a:defRPr sz="1200" b="1">
+              <a:defRPr sz="1100" b="1">
                 <a:solidFill>
                   <a:srgbClr val="BF9A4A"/>
                 </a:solidFill>
@@ -9093,8 +9093,8 @@
         </p:nvSpPr>
         <p:spPr>
           <a:xfrm>
-            <a:off x="0" y="6263640"/>
-            <a:ext cx="411480" cy="457200"/>
+            <a:off x="0" y="6309360"/>
+            <a:ext cx="411480" cy="411480"/>
           </a:xfrm>
           <a:prstGeom prst="rect">
             <a:avLst/>
@@ -9102,13 +9102,13 @@
           <a:noFill/>
         </p:spPr>
         <p:txBody>
-          <a:bodyPr wrap="none">
+          <a:bodyPr wrap="none" lIns="0" rIns="0">
             <a:spAutoFit/>
           </a:bodyPr>
           <a:lstStyle/>
           <a:p>
             <a:pPr algn="ctr">
-              <a:defRPr sz="1200" b="1">
+              <a:defRPr sz="1100" b="1">
                 <a:solidFill>
                   <a:srgbClr val="BF9A4A"/>
                 </a:solidFill>
@@ -9415,8 +9415,8 @@
         </p:nvSpPr>
         <p:spPr>
           <a:xfrm>
-            <a:off x="0" y="6263640"/>
-            <a:ext cx="411480" cy="457200"/>
+            <a:off x="0" y="6309360"/>
+            <a:ext cx="411480" cy="411480"/>
           </a:xfrm>
           <a:prstGeom prst="rect">
             <a:avLst/>
@@ -9424,13 +9424,13 @@
           <a:noFill/>
         </p:spPr>
         <p:txBody>
-          <a:bodyPr wrap="none">
+          <a:bodyPr wrap="none" lIns="0" rIns="0">
             <a:spAutoFit/>
           </a:bodyPr>
           <a:lstStyle/>
           <a:p>
             <a:pPr algn="ctr">
-              <a:defRPr sz="1200" b="1">
+              <a:defRPr sz="1100" b="1">
                 <a:solidFill>
                   <a:srgbClr val="BF9A4A"/>
                 </a:solidFill>

</xml_diff>